<commit_message>
add HtmlBackend + polish example.docx/.pptx templates
</commit_message>
<xml_diff>
--- a/src/dash_reportbuilder/templates/example.pptx
+++ b/src/dash_reportbuilder/templates/example.pptx
@@ -4,6 +4,9 @@
   <p:sldMasterIdLst>
     <p:sldMasterId id="2147483648" r:id="rId1"/>
   </p:sldMasterIdLst>
+  <p:sldIdLst>
+    <p:sldId id="256" r:id="rId7"/>
+  </p:sldIdLst>
   <p:sldSz cx="12191695" cy="6858000" type="screen4x3"/>
   <p:notesSz cx="6858000" cy="9144000"/>
   <p:defaultTextStyle>
@@ -3123,6 +3126,121 @@
     </p:otherStyle>
   </p:txStyles>
 </p:sldMaster>
+</file>
+
+<file path=ppt/slides/slide1.xml><?xml version="1.0" encoding="utf-8"?>
+<p:sld xmlns:a="http://schemas.openxmlformats.org/drawingml/2006/main" xmlns:p="http://schemas.openxmlformats.org/presentationml/2006/main" xmlns:r="http://schemas.openxmlformats.org/officeDocument/2006/relationships">
+  <p:cSld>
+    <p:spTree>
+      <p:nvGrpSpPr>
+        <p:cNvPr id="1" name=""/>
+        <p:cNvGrpSpPr/>
+        <p:nvPr/>
+      </p:nvGrpSpPr>
+      <p:grpSpPr/>
+      <p:sp>
+        <p:nvSpPr>
+          <p:cNvPr id="2" name="Title 1"/>
+          <p:cNvSpPr>
+            <a:spLocks noGrp="1"/>
+          </p:cNvSpPr>
+          <p:nvPr>
+            <p:ph type="ctrTitle"/>
+          </p:nvPr>
+        </p:nvSpPr>
+        <p:spPr/>
+        <p:txBody>
+          <a:bodyPr/>
+          <a:lstStyle/>
+          <a:p>
+            <a:r>
+              <a:rPr b="1" sz="4000">
+                <a:solidFill>
+                  <a:srgbClr val="2563EB"/>
+                </a:solidFill>
+                <a:latin typeface="Calibri"/>
+              </a:rPr>
+              <a:t>Report</a:t>
+            </a:r>
+          </a:p>
+        </p:txBody>
+      </p:sp>
+      <p:sp>
+        <p:nvSpPr>
+          <p:cNvPr id="3" name="Subtitle 2"/>
+          <p:cNvSpPr>
+            <a:spLocks noGrp="1"/>
+          </p:cNvSpPr>
+          <p:nvPr>
+            <p:ph type="subTitle" idx="1"/>
+          </p:nvPr>
+        </p:nvSpPr>
+        <p:spPr/>
+        <p:txBody>
+          <a:bodyPr/>
+          <a:lstStyle/>
+          <a:p>
+            <a:r>
+              <a:rPr sz="2000">
+                <a:solidFill>
+                  <a:srgbClr val="64748B"/>
+                </a:solidFill>
+                <a:latin typeface="Calibri"/>
+              </a:rPr>
+              <a:t>Generated with dash-reportbuilder</a:t>
+            </a:r>
+          </a:p>
+        </p:txBody>
+      </p:sp>
+      <p:sp>
+        <p:nvSpPr>
+          <p:cNvPr id="4" name="Rectangle 3"/>
+          <p:cNvSpPr/>
+          <p:nvPr/>
+        </p:nvSpPr>
+        <p:spPr>
+          <a:xfrm>
+            <a:off x="0" y="0"/>
+            <a:ext cx="12191695" cy="228600"/>
+          </a:xfrm>
+          <a:prstGeom prst="rect">
+            <a:avLst/>
+          </a:prstGeom>
+          <a:solidFill>
+            <a:srgbClr val="2563EB"/>
+          </a:solidFill>
+          <a:ln>
+            <a:noFill/>
+          </a:ln>
+        </p:spPr>
+        <p:style>
+          <a:lnRef idx="1">
+            <a:schemeClr val="accent1"/>
+          </a:lnRef>
+          <a:fillRef idx="3">
+            <a:schemeClr val="accent1"/>
+          </a:fillRef>
+          <a:effectRef idx="2">
+            <a:schemeClr val="accent1"/>
+          </a:effectRef>
+          <a:fontRef idx="minor">
+            <a:schemeClr val="lt1"/>
+          </a:fontRef>
+        </p:style>
+        <p:txBody>
+          <a:bodyPr rtlCol="0" anchor="ctr"/>
+          <a:lstStyle/>
+          <a:p>
+            <a:pPr algn="ctr"/>
+          </a:p>
+        </p:txBody>
+      </p:sp>
+    </p:spTree>
+  </p:cSld>
+  <p:clrMapOvr>
+    <a:masterClrMapping/>
+  </p:clrMapOvr>
+</p:sld>
 </file>
 
 <file path=ppt/theme/theme1.xml><?xml version="1.0" encoding="utf-8"?>

</xml_diff>